<commit_message>
finish formant section and start VOT
</commit_message>
<xml_diff>
--- a/blog/vasta/images/_images.pptx
+++ b/blog/vasta/images/_images.pptx
@@ -6,7 +6,7 @@
   </p:sldMasterIdLst>
   <p:sldIdLst>
     <p:sldId id="256" r:id="rId2"/>
-    <p:sldId id="257" r:id="rId3"/>
+    <p:sldId id="258" r:id="rId3"/>
   </p:sldIdLst>
   <p:sldSz cx="12192000" cy="6858000"/>
   <p:notesSz cx="6858000" cy="9144000"/>
@@ -105,6 +105,11 @@
       </a:defRPr>
     </a:lvl9pPr>
   </p:defaultTextStyle>
+  <p:extLst>
+    <p:ext uri="{EFAFB233-063F-42B5-8137-9DF3F51BA10A}">
+      <p15:sldGuideLst xmlns:p15="http://schemas.microsoft.com/office/powerpoint/2012/main"/>
+    </p:ext>
+  </p:extLst>
 </p:presentation>
 </file>
 
@@ -255,7 +260,7 @@
           <a:p>
             <a:fld id="{55C7F848-85AA-D044-9344-059541484ED3}" type="datetimeFigureOut">
               <a:rPr lang="en-US" smtClean="0"/>
-              <a:t>9/10/19</a:t>
+              <a:t>7/23/26</a:t>
             </a:fld>
             <a:endParaRPr lang="en-US"/>
           </a:p>
@@ -453,7 +458,7 @@
           <a:p>
             <a:fld id="{55C7F848-85AA-D044-9344-059541484ED3}" type="datetimeFigureOut">
               <a:rPr lang="en-US" smtClean="0"/>
-              <a:t>9/10/19</a:t>
+              <a:t>7/23/26</a:t>
             </a:fld>
             <a:endParaRPr lang="en-US"/>
           </a:p>
@@ -661,7 +666,7 @@
           <a:p>
             <a:fld id="{55C7F848-85AA-D044-9344-059541484ED3}" type="datetimeFigureOut">
               <a:rPr lang="en-US" smtClean="0"/>
-              <a:t>9/10/19</a:t>
+              <a:t>7/23/26</a:t>
             </a:fld>
             <a:endParaRPr lang="en-US"/>
           </a:p>
@@ -859,7 +864,7 @@
           <a:p>
             <a:fld id="{55C7F848-85AA-D044-9344-059541484ED3}" type="datetimeFigureOut">
               <a:rPr lang="en-US" smtClean="0"/>
-              <a:t>9/10/19</a:t>
+              <a:t>7/23/26</a:t>
             </a:fld>
             <a:endParaRPr lang="en-US"/>
           </a:p>
@@ -1134,7 +1139,7 @@
           <a:p>
             <a:fld id="{55C7F848-85AA-D044-9344-059541484ED3}" type="datetimeFigureOut">
               <a:rPr lang="en-US" smtClean="0"/>
-              <a:t>9/10/19</a:t>
+              <a:t>7/23/26</a:t>
             </a:fld>
             <a:endParaRPr lang="en-US"/>
           </a:p>
@@ -1399,7 +1404,7 @@
           <a:p>
             <a:fld id="{55C7F848-85AA-D044-9344-059541484ED3}" type="datetimeFigureOut">
               <a:rPr lang="en-US" smtClean="0"/>
-              <a:t>9/10/19</a:t>
+              <a:t>7/23/26</a:t>
             </a:fld>
             <a:endParaRPr lang="en-US"/>
           </a:p>
@@ -1811,7 +1816,7 @@
           <a:p>
             <a:fld id="{55C7F848-85AA-D044-9344-059541484ED3}" type="datetimeFigureOut">
               <a:rPr lang="en-US" smtClean="0"/>
-              <a:t>9/10/19</a:t>
+              <a:t>7/23/26</a:t>
             </a:fld>
             <a:endParaRPr lang="en-US"/>
           </a:p>
@@ -1952,7 +1957,7 @@
           <a:p>
             <a:fld id="{55C7F848-85AA-D044-9344-059541484ED3}" type="datetimeFigureOut">
               <a:rPr lang="en-US" smtClean="0"/>
-              <a:t>9/10/19</a:t>
+              <a:t>7/23/26</a:t>
             </a:fld>
             <a:endParaRPr lang="en-US"/>
           </a:p>
@@ -2065,7 +2070,7 @@
           <a:p>
             <a:fld id="{55C7F848-85AA-D044-9344-059541484ED3}" type="datetimeFigureOut">
               <a:rPr lang="en-US" smtClean="0"/>
-              <a:t>9/10/19</a:t>
+              <a:t>7/23/26</a:t>
             </a:fld>
             <a:endParaRPr lang="en-US"/>
           </a:p>
@@ -2376,7 +2381,7 @@
           <a:p>
             <a:fld id="{55C7F848-85AA-D044-9344-059541484ED3}" type="datetimeFigureOut">
               <a:rPr lang="en-US" smtClean="0"/>
-              <a:t>9/10/19</a:t>
+              <a:t>7/23/26</a:t>
             </a:fld>
             <a:endParaRPr lang="en-US"/>
           </a:p>
@@ -2664,7 +2669,7 @@
           <a:p>
             <a:fld id="{55C7F848-85AA-D044-9344-059541484ED3}" type="datetimeFigureOut">
               <a:rPr lang="en-US" smtClean="0"/>
-              <a:t>9/10/19</a:t>
+              <a:t>7/23/26</a:t>
             </a:fld>
             <a:endParaRPr lang="en-US"/>
           </a:p>
@@ -2905,7 +2910,7 @@
           <a:p>
             <a:fld id="{55C7F848-85AA-D044-9344-059541484ED3}" type="datetimeFigureOut">
               <a:rPr lang="en-US" smtClean="0"/>
-              <a:t>9/10/19</a:t>
+              <a:t>7/23/26</a:t>
             </a:fld>
             <a:endParaRPr lang="en-US"/>
           </a:p>
@@ -4497,10 +4502,322 @@
           <a:chExt cx="0" cy="0"/>
         </a:xfrm>
       </p:grpSpPr>
+      <p:pic>
+        <p:nvPicPr>
+          <p:cNvPr id="7" name="Picture 6">
+            <a:extLst>
+              <a:ext uri="{FF2B5EF4-FFF2-40B4-BE49-F238E27FC236}">
+                <a16:creationId xmlns:a16="http://schemas.microsoft.com/office/drawing/2014/main" id="{9ED20FF8-7E24-BAB1-A4B5-D872E5006F68}"/>
+              </a:ext>
+            </a:extLst>
+          </p:cNvPr>
+          <p:cNvPicPr>
+            <a:picLocks noChangeAspect="1"/>
+          </p:cNvPicPr>
+          <p:nvPr/>
+        </p:nvPicPr>
+        <p:blipFill>
+          <a:blip r:embed="rId2"/>
+          <a:stretch>
+            <a:fillRect/>
+          </a:stretch>
+        </p:blipFill>
+        <p:spPr>
+          <a:xfrm>
+            <a:off x="99675" y="0"/>
+            <a:ext cx="11992647" cy="6858000"/>
+          </a:xfrm>
+          <a:prstGeom prst="rect">
+            <a:avLst/>
+          </a:prstGeom>
+        </p:spPr>
+      </p:pic>
+      <p:cxnSp>
+        <p:nvCxnSpPr>
+          <p:cNvPr id="9" name="Straight Arrow Connector 8">
+            <a:extLst>
+              <a:ext uri="{FF2B5EF4-FFF2-40B4-BE49-F238E27FC236}">
+                <a16:creationId xmlns:a16="http://schemas.microsoft.com/office/drawing/2014/main" id="{08437D5A-60D6-0E6F-D4ED-3DC14D546FBE}"/>
+              </a:ext>
+            </a:extLst>
+          </p:cNvPr>
+          <p:cNvCxnSpPr>
+            <a:cxnSpLocks/>
+          </p:cNvCxnSpPr>
+          <p:nvPr/>
+        </p:nvCxnSpPr>
+        <p:spPr>
+          <a:xfrm>
+            <a:off x="4712393" y="3679559"/>
+            <a:ext cx="1650657" cy="0"/>
+          </a:xfrm>
+          <a:prstGeom prst="straightConnector1">
+            <a:avLst/>
+          </a:prstGeom>
+          <a:ln>
+            <a:solidFill>
+              <a:srgbClr val="FF0000"/>
+            </a:solidFill>
+            <a:headEnd type="triangle"/>
+            <a:tailEnd type="triangle"/>
+          </a:ln>
+        </p:spPr>
+        <p:style>
+          <a:lnRef idx="2">
+            <a:schemeClr val="accent1"/>
+          </a:lnRef>
+          <a:fillRef idx="0">
+            <a:schemeClr val="accent1"/>
+          </a:fillRef>
+          <a:effectRef idx="1">
+            <a:schemeClr val="accent1"/>
+          </a:effectRef>
+          <a:fontRef idx="minor">
+            <a:schemeClr val="tx1"/>
+          </a:fontRef>
+        </p:style>
+      </p:cxnSp>
+      <p:cxnSp>
+        <p:nvCxnSpPr>
+          <p:cNvPr id="12" name="Straight Arrow Connector 11">
+            <a:extLst>
+              <a:ext uri="{FF2B5EF4-FFF2-40B4-BE49-F238E27FC236}">
+                <a16:creationId xmlns:a16="http://schemas.microsoft.com/office/drawing/2014/main" id="{6CB94A48-253A-E61C-2009-33855BC37CF0}"/>
+              </a:ext>
+            </a:extLst>
+          </p:cNvPr>
+          <p:cNvCxnSpPr>
+            <a:cxnSpLocks/>
+          </p:cNvCxnSpPr>
+          <p:nvPr/>
+        </p:nvCxnSpPr>
+        <p:spPr>
+          <a:xfrm>
+            <a:off x="6458700" y="3679559"/>
+            <a:ext cx="1288531" cy="0"/>
+          </a:xfrm>
+          <a:prstGeom prst="straightConnector1">
+            <a:avLst/>
+          </a:prstGeom>
+          <a:ln>
+            <a:solidFill>
+              <a:srgbClr val="FF0000"/>
+            </a:solidFill>
+            <a:headEnd type="triangle"/>
+            <a:tailEnd type="triangle"/>
+          </a:ln>
+        </p:spPr>
+        <p:style>
+          <a:lnRef idx="2">
+            <a:schemeClr val="accent1"/>
+          </a:lnRef>
+          <a:fillRef idx="0">
+            <a:schemeClr val="accent1"/>
+          </a:fillRef>
+          <a:effectRef idx="1">
+            <a:schemeClr val="accent1"/>
+          </a:effectRef>
+          <a:fontRef idx="minor">
+            <a:schemeClr val="tx1"/>
+          </a:fontRef>
+        </p:style>
+      </p:cxnSp>
+      <p:sp>
+        <p:nvSpPr>
+          <p:cNvPr id="14" name="TextBox 13">
+            <a:extLst>
+              <a:ext uri="{FF2B5EF4-FFF2-40B4-BE49-F238E27FC236}">
+                <a16:creationId xmlns:a16="http://schemas.microsoft.com/office/drawing/2014/main" id="{1C6383E5-6B35-1C15-E798-AF4444457A66}"/>
+              </a:ext>
+            </a:extLst>
+          </p:cNvPr>
+          <p:cNvSpPr txBox="1"/>
+          <p:nvPr/>
+        </p:nvSpPr>
+        <p:spPr>
+          <a:xfrm>
+            <a:off x="5102655" y="3723888"/>
+            <a:ext cx="870132" cy="306467"/>
+          </a:xfrm>
+          <a:prstGeom prst="roundRect">
+            <a:avLst/>
+          </a:prstGeom>
+          <a:solidFill>
+            <a:srgbClr val="FFFFFF">
+              <a:alpha val="50196"/>
+            </a:srgbClr>
+          </a:solidFill>
+          <a:ln>
+            <a:solidFill>
+              <a:srgbClr val="FF0000"/>
+            </a:solidFill>
+          </a:ln>
+        </p:spPr>
+        <p:txBody>
+          <a:bodyPr wrap="square" rtlCol="0">
+            <a:spAutoFit/>
+          </a:bodyPr>
+          <a:lstStyle/>
+          <a:p>
+            <a:pPr algn="ctr"/>
+            <a:r>
+              <a:rPr lang="en-US" sz="1200" dirty="0">
+                <a:solidFill>
+                  <a:srgbClr val="FF0000"/>
+                </a:solidFill>
+              </a:rPr>
+              <a:t>closure</a:t>
+            </a:r>
+          </a:p>
+        </p:txBody>
+      </p:sp>
+      <p:sp>
+        <p:nvSpPr>
+          <p:cNvPr id="16" name="TextBox 15">
+            <a:extLst>
+              <a:ext uri="{FF2B5EF4-FFF2-40B4-BE49-F238E27FC236}">
+                <a16:creationId xmlns:a16="http://schemas.microsoft.com/office/drawing/2014/main" id="{8B30AA0E-5849-3AD5-862C-27C36E5937E2}"/>
+              </a:ext>
+            </a:extLst>
+          </p:cNvPr>
+          <p:cNvSpPr txBox="1"/>
+          <p:nvPr/>
+        </p:nvSpPr>
+        <p:spPr>
+          <a:xfrm>
+            <a:off x="6573918" y="3723888"/>
+            <a:ext cx="1058093" cy="306467"/>
+          </a:xfrm>
+          <a:prstGeom prst="roundRect">
+            <a:avLst/>
+          </a:prstGeom>
+          <a:solidFill>
+            <a:srgbClr val="FFFFFF">
+              <a:alpha val="50196"/>
+            </a:srgbClr>
+          </a:solidFill>
+          <a:ln>
+            <a:solidFill>
+              <a:srgbClr val="FF0000"/>
+            </a:solidFill>
+          </a:ln>
+        </p:spPr>
+        <p:txBody>
+          <a:bodyPr wrap="square" rtlCol="0">
+            <a:spAutoFit/>
+          </a:bodyPr>
+          <a:lstStyle/>
+          <a:p>
+            <a:pPr algn="ctr"/>
+            <a:r>
+              <a:rPr lang="en-US" sz="1200" dirty="0">
+                <a:solidFill>
+                  <a:srgbClr val="FF0000"/>
+                </a:solidFill>
+              </a:rPr>
+              <a:t>aspiration</a:t>
+            </a:r>
+          </a:p>
+        </p:txBody>
+      </p:sp>
+      <p:cxnSp>
+        <p:nvCxnSpPr>
+          <p:cNvPr id="18" name="Straight Arrow Connector 17">
+            <a:extLst>
+              <a:ext uri="{FF2B5EF4-FFF2-40B4-BE49-F238E27FC236}">
+                <a16:creationId xmlns:a16="http://schemas.microsoft.com/office/drawing/2014/main" id="{2F011752-6152-8B43-1A15-59CFD2702C0F}"/>
+              </a:ext>
+            </a:extLst>
+          </p:cNvPr>
+          <p:cNvCxnSpPr>
+            <a:cxnSpLocks/>
+          </p:cNvCxnSpPr>
+          <p:nvPr/>
+        </p:nvCxnSpPr>
+        <p:spPr>
+          <a:xfrm flipV="1">
+            <a:off x="6393810" y="3022422"/>
+            <a:ext cx="0" cy="475787"/>
+          </a:xfrm>
+          <a:prstGeom prst="straightConnector1">
+            <a:avLst/>
+          </a:prstGeom>
+          <a:ln cap="rnd">
+            <a:solidFill>
+              <a:srgbClr val="FF0000"/>
+            </a:solidFill>
+            <a:headEnd type="triangle"/>
+            <a:tailEnd type="none"/>
+          </a:ln>
+        </p:spPr>
+        <p:style>
+          <a:lnRef idx="2">
+            <a:schemeClr val="accent1"/>
+          </a:lnRef>
+          <a:fillRef idx="0">
+            <a:schemeClr val="accent1"/>
+          </a:fillRef>
+          <a:effectRef idx="1">
+            <a:schemeClr val="accent1"/>
+          </a:effectRef>
+          <a:fontRef idx="minor">
+            <a:schemeClr val="tx1"/>
+          </a:fontRef>
+        </p:style>
+      </p:cxnSp>
+      <p:sp>
+        <p:nvSpPr>
+          <p:cNvPr id="20" name="TextBox 19">
+            <a:extLst>
+              <a:ext uri="{FF2B5EF4-FFF2-40B4-BE49-F238E27FC236}">
+                <a16:creationId xmlns:a16="http://schemas.microsoft.com/office/drawing/2014/main" id="{248E2AC2-C4AE-B3D1-6298-E6856BEE210A}"/>
+              </a:ext>
+            </a:extLst>
+          </p:cNvPr>
+          <p:cNvSpPr txBox="1"/>
+          <p:nvPr/>
+        </p:nvSpPr>
+        <p:spPr>
+          <a:xfrm>
+            <a:off x="5958744" y="2671627"/>
+            <a:ext cx="870132" cy="306467"/>
+          </a:xfrm>
+          <a:prstGeom prst="roundRect">
+            <a:avLst/>
+          </a:prstGeom>
+          <a:solidFill>
+            <a:srgbClr val="FFFFFF">
+              <a:alpha val="50196"/>
+            </a:srgbClr>
+          </a:solidFill>
+          <a:ln>
+            <a:solidFill>
+              <a:srgbClr val="FF0000"/>
+            </a:solidFill>
+          </a:ln>
+        </p:spPr>
+        <p:txBody>
+          <a:bodyPr wrap="square" rtlCol="0">
+            <a:spAutoFit/>
+          </a:bodyPr>
+          <a:lstStyle/>
+          <a:p>
+            <a:pPr algn="ctr"/>
+            <a:r>
+              <a:rPr lang="en-US" sz="1200" dirty="0">
+                <a:solidFill>
+                  <a:srgbClr val="FF0000"/>
+                </a:solidFill>
+              </a:rPr>
+              <a:t>burst</a:t>
+            </a:r>
+          </a:p>
+        </p:txBody>
+      </p:sp>
     </p:spTree>
     <p:extLst>
       <p:ext uri="{BB962C8B-B14F-4D97-AF65-F5344CB8AC3E}">
-        <p14:creationId xmlns:p14="http://schemas.microsoft.com/office/powerpoint/2010/main" val="3222603947"/>
+        <p14:creationId xmlns:p14="http://schemas.microsoft.com/office/powerpoint/2010/main" val="405983897"/>
       </p:ext>
     </p:extLst>
   </p:cSld>

</xml_diff>